<commit_message>
Remove empty placeholders auto-added to every slide
</commit_message>
<xml_diff>
--- a/dist/JCHRES_company_profile_sample.pptx
+++ b/dist/JCHRES_company_profile_sample.pptx
@@ -5302,36 +5302,6 @@
       </p:sp>
       <p:sp>
         <p:nvSpPr>
-          <p:cNvPr id="28" name="Text 3"/>
-          <p:cNvSpPr/>
-          <p:nvPr>
-            <p:ph idx="105" type="body" hasCustomPrompt="1"/>
-          </p:nvPr>
-        </p:nvSpPr>
-        <p:spPr>
-          <a:xfrm>
-            <a:off x="640080" y="1691640"/>
-            <a:ext cx="10908792" cy="4453128"/>
-          </a:xfrm>
-          <a:prstGeom prst="rect">
-            <a:avLst/>
-          </a:prstGeom>
-          <a:noFill/>
-          <a:ln/>
-        </p:spPr>
-        <p:txBody>
-          <a:bodyPr wrap="square" rtlCol="0" anchor="t"/>
-          <a:lstStyle/>
-          <a:p>
-            <a:pPr indent="0" marL="0">
-              <a:buNone/>
-            </a:pPr>
-            <a:endParaRPr lang="en-US" sz="2400" dirty="0"/>
-          </a:p>
-        </p:txBody>
-      </p:sp>
-      <p:sp>
-        <p:nvSpPr>
           <p:cNvPr id="25" name="Slide Number Placeholder 0"/>
           <p:cNvSpPr>
             <a:spLocks noGrp="1"/>
@@ -6023,36 +5993,6 @@
       </p:sp>
       <p:sp>
         <p:nvSpPr>
-          <p:cNvPr id="20" name="Text 3"/>
-          <p:cNvSpPr/>
-          <p:nvPr>
-            <p:ph idx="105" type="body" hasCustomPrompt="1"/>
-          </p:nvPr>
-        </p:nvSpPr>
-        <p:spPr>
-          <a:xfrm>
-            <a:off x="640080" y="1691640"/>
-            <a:ext cx="10908792" cy="4453128"/>
-          </a:xfrm>
-          <a:prstGeom prst="rect">
-            <a:avLst/>
-          </a:prstGeom>
-          <a:noFill/>
-          <a:ln/>
-        </p:spPr>
-        <p:txBody>
-          <a:bodyPr wrap="square" rtlCol="0" anchor="t"/>
-          <a:lstStyle/>
-          <a:p>
-            <a:pPr indent="0" marL="0">
-              <a:buNone/>
-            </a:pPr>
-            <a:endParaRPr lang="en-US" sz="2400" dirty="0"/>
-          </a:p>
-        </p:txBody>
-      </p:sp>
-      <p:sp>
-        <p:nvSpPr>
           <p:cNvPr id="25" name="Slide Number Placeholder 0"/>
           <p:cNvSpPr>
             <a:spLocks noGrp="1"/>
@@ -6701,36 +6641,6 @@
       </p:sp>
       <p:sp>
         <p:nvSpPr>
-          <p:cNvPr id="19" name="Text 3"/>
-          <p:cNvSpPr/>
-          <p:nvPr>
-            <p:ph idx="105" type="body" hasCustomPrompt="1"/>
-          </p:nvPr>
-        </p:nvSpPr>
-        <p:spPr>
-          <a:xfrm>
-            <a:off x="640080" y="1691640"/>
-            <a:ext cx="10908792" cy="4453128"/>
-          </a:xfrm>
-          <a:prstGeom prst="rect">
-            <a:avLst/>
-          </a:prstGeom>
-          <a:noFill/>
-          <a:ln/>
-        </p:spPr>
-        <p:txBody>
-          <a:bodyPr wrap="square" rtlCol="0" anchor="t"/>
-          <a:lstStyle/>
-          <a:p>
-            <a:pPr indent="0" marL="0">
-              <a:buNone/>
-            </a:pPr>
-            <a:endParaRPr lang="en-US" sz="2400" dirty="0"/>
-          </a:p>
-        </p:txBody>
-      </p:sp>
-      <p:sp>
-        <p:nvSpPr>
           <p:cNvPr id="25" name="Slide Number Placeholder 0"/>
           <p:cNvSpPr>
             <a:spLocks noGrp="1"/>
@@ -7583,36 +7493,6 @@
               <a:t>生物統計学、医療経済学</a:t>
             </a:r>
             <a:endParaRPr lang="ja-JP" sz="2400" dirty="0"/>
-          </a:p>
-        </p:txBody>
-      </p:sp>
-      <p:sp>
-        <p:nvSpPr>
-          <p:cNvPr id="24" name="Text 3"/>
-          <p:cNvSpPr/>
-          <p:nvPr>
-            <p:ph idx="105" type="body" hasCustomPrompt="1"/>
-          </p:nvPr>
-        </p:nvSpPr>
-        <p:spPr>
-          <a:xfrm>
-            <a:off x="640080" y="1691640"/>
-            <a:ext cx="10908792" cy="4453128"/>
-          </a:xfrm>
-          <a:prstGeom prst="rect">
-            <a:avLst/>
-          </a:prstGeom>
-          <a:noFill/>
-          <a:ln/>
-        </p:spPr>
-        <p:txBody>
-          <a:bodyPr wrap="square" rtlCol="0" anchor="t"/>
-          <a:lstStyle/>
-          <a:p>
-            <a:pPr indent="0" marL="0">
-              <a:buNone/>
-            </a:pPr>
-            <a:endParaRPr lang="en-US" sz="2400" dirty="0"/>
           </a:p>
         </p:txBody>
       </p:sp>
@@ -8629,36 +8509,6 @@
       </p:graphicFrame>
       <p:sp>
         <p:nvSpPr>
-          <p:cNvPr id="5" name="Text 3"/>
-          <p:cNvSpPr/>
-          <p:nvPr>
-            <p:ph idx="105" type="body" hasCustomPrompt="1"/>
-          </p:nvPr>
-        </p:nvSpPr>
-        <p:spPr>
-          <a:xfrm>
-            <a:off x="640080" y="1691640"/>
-            <a:ext cx="10908792" cy="4453128"/>
-          </a:xfrm>
-          <a:prstGeom prst="rect">
-            <a:avLst/>
-          </a:prstGeom>
-          <a:noFill/>
-          <a:ln/>
-        </p:spPr>
-        <p:txBody>
-          <a:bodyPr wrap="square" rtlCol="0" anchor="t"/>
-          <a:lstStyle/>
-          <a:p>
-            <a:pPr indent="0" marL="0">
-              <a:buNone/>
-            </a:pPr>
-            <a:endParaRPr lang="en-US" sz="2400" dirty="0"/>
-          </a:p>
-        </p:txBody>
-      </p:sp>
-      <p:sp>
-        <p:nvSpPr>
           <p:cNvPr id="25" name="Slide Number Placeholder 0"/>
           <p:cNvSpPr>
             <a:spLocks noGrp="1"/>

</xml_diff>